<commit_message>
Fix PowerPoint deck XML compatibility
</commit_message>
<xml_diff>
--- a/assets/One_Win_Final_BP_Investor_Web_Deck.pptx
+++ b/assets/One_Win_Final_BP_Investor_Web_Deck.pptx
@@ -2725,9 +2725,7 @@
             <a:ext cx="2011680" cy="438912"/>
           </a:xfrm>
           <a:prstGeom prst="rect">
-            <a:avLst>
-              <a:gd name="adj" fmla="val 10417"/>
-            </a:avLst>
+            <a:avLst/>
           </a:prstGeom>
           <a:solidFill>
             <a:srgbClr val="10281E"/>
@@ -2787,7 +2785,7 @@
         <p:spPr>
           <a:xfrm>
             <a:off x="850392" y="6437376"/>
-            <a:ext cx="1682496" cy="-347472"/>
+            <a:ext cx="1682496" cy="201168"/>
           </a:xfrm>
           <a:prstGeom prst="rect">
             <a:avLst/>
@@ -2828,9 +2826,7 @@
             <a:ext cx="2286000" cy="438912"/>
           </a:xfrm>
           <a:prstGeom prst="rect">
-            <a:avLst>
-              <a:gd name="adj" fmla="val 10417"/>
-            </a:avLst>
+            <a:avLst/>
           </a:prstGeom>
           <a:solidFill>
             <a:srgbClr val="10281E"/>
@@ -2890,7 +2886,7 @@
         <p:spPr>
           <a:xfrm>
             <a:off x="2999232" y="6437376"/>
-            <a:ext cx="1956816" cy="-347472"/>
+            <a:ext cx="1956816" cy="201168"/>
           </a:xfrm>
           <a:prstGeom prst="rect">
             <a:avLst/>
@@ -2931,9 +2927,7 @@
             <a:ext cx="2011680" cy="438912"/>
           </a:xfrm>
           <a:prstGeom prst="rect">
-            <a:avLst>
-              <a:gd name="adj" fmla="val 10417"/>
-            </a:avLst>
+            <a:avLst/>
           </a:prstGeom>
           <a:solidFill>
             <a:srgbClr val="10281E"/>
@@ -2993,7 +2987,7 @@
         <p:spPr>
           <a:xfrm>
             <a:off x="5468112" y="6437376"/>
-            <a:ext cx="1682496" cy="-347472"/>
+            <a:ext cx="1682496" cy="201168"/>
           </a:xfrm>
           <a:prstGeom prst="rect">
             <a:avLst/>
@@ -3205,9 +3199,7 @@
             <a:ext cx="3154680" cy="2286000"/>
           </a:xfrm>
           <a:prstGeom prst="rect">
-            <a:avLst>
-              <a:gd name="adj" fmla="val 2000"/>
-            </a:avLst>
+            <a:avLst/>
           </a:prstGeom>
           <a:solidFill>
             <a:srgbClr val="FFFFFF"/>
@@ -3308,9 +3300,7 @@
             <a:ext cx="3154680" cy="2286000"/>
           </a:xfrm>
           <a:prstGeom prst="rect">
-            <a:avLst>
-              <a:gd name="adj" fmla="val 2000"/>
-            </a:avLst>
+            <a:avLst/>
           </a:prstGeom>
           <a:solidFill>
             <a:srgbClr val="FFFFFF"/>
@@ -3411,9 +3401,7 @@
             <a:ext cx="3154680" cy="2286000"/>
           </a:xfrm>
           <a:prstGeom prst="rect">
-            <a:avLst>
-              <a:gd name="adj" fmla="val 2000"/>
-            </a:avLst>
+            <a:avLst/>
           </a:prstGeom>
           <a:solidFill>
             <a:srgbClr val="FFFFFF"/>
@@ -3838,9 +3826,7 @@
             <a:ext cx="2423160" cy="1115568"/>
           </a:xfrm>
           <a:prstGeom prst="rect">
-            <a:avLst>
-              <a:gd name="adj" fmla="val 4098"/>
-            </a:avLst>
+            <a:avLst/>
           </a:prstGeom>
           <a:solidFill>
             <a:srgbClr val="10281E"/>
@@ -3941,9 +3927,7 @@
             <a:ext cx="2423160" cy="1115568"/>
           </a:xfrm>
           <a:prstGeom prst="rect">
-            <a:avLst>
-              <a:gd name="adj" fmla="val 4098"/>
-            </a:avLst>
+            <a:avLst/>
           </a:prstGeom>
           <a:solidFill>
             <a:srgbClr val="10281E"/>
@@ -4044,9 +4028,7 @@
             <a:ext cx="2423160" cy="1115568"/>
           </a:xfrm>
           <a:prstGeom prst="rect">
-            <a:avLst>
-              <a:gd name="adj" fmla="val 4098"/>
-            </a:avLst>
+            <a:avLst/>
           </a:prstGeom>
           <a:solidFill>
             <a:srgbClr val="10281E"/>
@@ -4318,9 +4300,7 @@
             <a:ext cx="2103120" cy="1371600"/>
           </a:xfrm>
           <a:prstGeom prst="rect">
-            <a:avLst>
-              <a:gd name="adj" fmla="val 3333"/>
-            </a:avLst>
+            <a:avLst/>
           </a:prstGeom>
           <a:solidFill>
             <a:srgbClr val="FFFFFF"/>
@@ -4446,9 +4426,7 @@
             <a:ext cx="2103120" cy="1371600"/>
           </a:xfrm>
           <a:prstGeom prst="rect">
-            <a:avLst>
-              <a:gd name="adj" fmla="val 3333"/>
-            </a:avLst>
+            <a:avLst/>
           </a:prstGeom>
           <a:solidFill>
             <a:srgbClr val="FFFFFF"/>
@@ -4574,9 +4552,7 @@
             <a:ext cx="2103120" cy="1371600"/>
           </a:xfrm>
           <a:prstGeom prst="rect">
-            <a:avLst>
-              <a:gd name="adj" fmla="val 3333"/>
-            </a:avLst>
+            <a:avLst/>
           </a:prstGeom>
           <a:solidFill>
             <a:srgbClr val="FFFFFF"/>
@@ -4702,9 +4678,7 @@
             <a:ext cx="2103120" cy="1371600"/>
           </a:xfrm>
           <a:prstGeom prst="rect">
-            <a:avLst>
-              <a:gd name="adj" fmla="val 3333"/>
-            </a:avLst>
+            <a:avLst/>
           </a:prstGeom>
           <a:solidFill>
             <a:srgbClr val="FFFFFF"/>
@@ -4976,9 +4950,7 @@
             <a:ext cx="10241280" cy="960120"/>
           </a:xfrm>
           <a:prstGeom prst="rect">
-            <a:avLst>
-              <a:gd name="adj" fmla="val 4762"/>
-            </a:avLst>
+            <a:avLst/>
           </a:prstGeom>
           <a:solidFill>
             <a:srgbClr val="1E3B2E"/>
@@ -5038,7 +5010,7 @@
         <p:spPr>
           <a:xfrm>
             <a:off x="1078992" y="2761488"/>
-            <a:ext cx="9912096" cy="173736"/>
+            <a:ext cx="9912096" cy="201168"/>
           </a:xfrm>
           <a:prstGeom prst="rect">
             <a:avLst/>
@@ -5079,9 +5051,7 @@
             <a:ext cx="9107424" cy="960120"/>
           </a:xfrm>
           <a:prstGeom prst="rect">
-            <a:avLst>
-              <a:gd name="adj" fmla="val 4762"/>
-            </a:avLst>
+            <a:avLst/>
           </a:prstGeom>
           <a:solidFill>
             <a:srgbClr val="FFFFFF"/>
@@ -5141,7 +5111,7 @@
         <p:spPr>
           <a:xfrm>
             <a:off x="1645920" y="3995928"/>
-            <a:ext cx="8778240" cy="173736"/>
+            <a:ext cx="8778240" cy="201168"/>
           </a:xfrm>
           <a:prstGeom prst="rect">
             <a:avLst/>
@@ -5182,9 +5152,7 @@
             <a:ext cx="7973568" cy="960120"/>
           </a:xfrm>
           <a:prstGeom prst="rect">
-            <a:avLst>
-              <a:gd name="adj" fmla="val 4762"/>
-            </a:avLst>
+            <a:avLst/>
           </a:prstGeom>
           <a:solidFill>
             <a:srgbClr val="FFFFFF"/>
@@ -5244,7 +5212,7 @@
         <p:spPr>
           <a:xfrm>
             <a:off x="2212848" y="5230368"/>
-            <a:ext cx="7644384" cy="173736"/>
+            <a:ext cx="7644384" cy="201168"/>
           </a:xfrm>
           <a:prstGeom prst="rect">
             <a:avLst/>
@@ -5456,9 +5424,7 @@
             <a:ext cx="2331720" cy="2514600"/>
           </a:xfrm>
           <a:prstGeom prst="rect">
-            <a:avLst>
-              <a:gd name="adj" fmla="val 1961"/>
-            </a:avLst>
+            <a:avLst/>
           </a:prstGeom>
           <a:solidFill>
             <a:srgbClr val="FFFFFF"/>
@@ -5554,7 +5520,7 @@
         <p:spPr>
           <a:xfrm>
             <a:off x="850392" y="3209544"/>
-            <a:ext cx="2002536" cy="1728216"/>
+            <a:ext cx="2002536" cy="1527048"/>
           </a:xfrm>
           <a:prstGeom prst="rect">
             <a:avLst/>
@@ -5595,9 +5561,7 @@
             <a:ext cx="2331720" cy="2514600"/>
           </a:xfrm>
           <a:prstGeom prst="rect">
-            <a:avLst>
-              <a:gd name="adj" fmla="val 1961"/>
-            </a:avLst>
+            <a:avLst/>
           </a:prstGeom>
           <a:solidFill>
             <a:srgbClr val="FFFFFF"/>
@@ -5693,7 +5657,7 @@
         <p:spPr>
           <a:xfrm>
             <a:off x="3639312" y="3209544"/>
-            <a:ext cx="2002536" cy="1728216"/>
+            <a:ext cx="2002536" cy="1527048"/>
           </a:xfrm>
           <a:prstGeom prst="rect">
             <a:avLst/>
@@ -5734,9 +5698,7 @@
             <a:ext cx="2331720" cy="2514600"/>
           </a:xfrm>
           <a:prstGeom prst="rect">
-            <a:avLst>
-              <a:gd name="adj" fmla="val 1961"/>
-            </a:avLst>
+            <a:avLst/>
           </a:prstGeom>
           <a:solidFill>
             <a:srgbClr val="FFFFFF"/>
@@ -5832,7 +5794,7 @@
         <p:spPr>
           <a:xfrm>
             <a:off x="6428232" y="3209544"/>
-            <a:ext cx="2002536" cy="1728216"/>
+            <a:ext cx="2002536" cy="1527048"/>
           </a:xfrm>
           <a:prstGeom prst="rect">
             <a:avLst/>
@@ -5873,9 +5835,7 @@
             <a:ext cx="2331720" cy="2514600"/>
           </a:xfrm>
           <a:prstGeom prst="rect">
-            <a:avLst>
-              <a:gd name="adj" fmla="val 1961"/>
-            </a:avLst>
+            <a:avLst/>
           </a:prstGeom>
           <a:solidFill>
             <a:srgbClr val="FFFFFF"/>
@@ -5971,7 +5931,7 @@
         <p:spPr>
           <a:xfrm>
             <a:off x="9217152" y="3209544"/>
-            <a:ext cx="2002536" cy="1728216"/>
+            <a:ext cx="2002536" cy="1527048"/>
           </a:xfrm>
           <a:prstGeom prst="rect">
             <a:avLst/>
@@ -6221,9 +6181,7 @@
             <a:ext cx="3017520" cy="2880360"/>
           </a:xfrm>
           <a:prstGeom prst="rect">
-            <a:avLst>
-              <a:gd name="adj" fmla="val 1587"/>
-            </a:avLst>
+            <a:avLst/>
           </a:prstGeom>
           <a:solidFill>
             <a:srgbClr val="FFFFFF"/>
@@ -7700,9 +7658,7 @@
             <a:ext cx="3154680" cy="2240280"/>
           </a:xfrm>
           <a:prstGeom prst="rect">
-            <a:avLst>
-              <a:gd name="adj" fmla="val 2041"/>
-            </a:avLst>
+            <a:avLst/>
           </a:prstGeom>
           <a:solidFill>
             <a:srgbClr val="FFFFFF"/>
@@ -7798,7 +7754,7 @@
         <p:spPr>
           <a:xfrm>
             <a:off x="877824" y="3236976"/>
-            <a:ext cx="2825496" cy="1453896"/>
+            <a:ext cx="2825496" cy="1252728"/>
           </a:xfrm>
           <a:prstGeom prst="rect">
             <a:avLst/>
@@ -7839,9 +7795,7 @@
             <a:ext cx="3154680" cy="2240280"/>
           </a:xfrm>
           <a:prstGeom prst="rect">
-            <a:avLst>
-              <a:gd name="adj" fmla="val 2041"/>
-            </a:avLst>
+            <a:avLst/>
           </a:prstGeom>
           <a:solidFill>
             <a:srgbClr val="FFFFFF"/>
@@ -7937,7 +7891,7 @@
         <p:spPr>
           <a:xfrm>
             <a:off x="4581144" y="3236976"/>
-            <a:ext cx="2825496" cy="1453896"/>
+            <a:ext cx="2825496" cy="1252728"/>
           </a:xfrm>
           <a:prstGeom prst="rect">
             <a:avLst/>
@@ -7978,9 +7932,7 @@
             <a:ext cx="3154680" cy="2240280"/>
           </a:xfrm>
           <a:prstGeom prst="rect">
-            <a:avLst>
-              <a:gd name="adj" fmla="val 2041"/>
-            </a:avLst>
+            <a:avLst/>
           </a:prstGeom>
           <a:solidFill>
             <a:srgbClr val="FFFFFF"/>
@@ -8076,7 +8028,7 @@
         <p:spPr>
           <a:xfrm>
             <a:off x="8284464" y="3236976"/>
-            <a:ext cx="2825496" cy="1453896"/>
+            <a:ext cx="2825496" cy="1252728"/>
           </a:xfrm>
           <a:prstGeom prst="rect">
             <a:avLst/>
@@ -9130,9 +9082,7 @@
             <a:ext cx="1874520" cy="877824"/>
           </a:xfrm>
           <a:prstGeom prst="rect">
-            <a:avLst>
-              <a:gd name="adj" fmla="val 5208"/>
-            </a:avLst>
+            <a:avLst/>
           </a:prstGeom>
           <a:solidFill>
             <a:srgbClr val="10281E"/>
@@ -9192,7 +9142,7 @@
         <p:spPr>
           <a:xfrm>
             <a:off x="896112" y="3218688"/>
-            <a:ext cx="1545336" cy="91440"/>
+            <a:ext cx="1545336" cy="201168"/>
           </a:xfrm>
           <a:prstGeom prst="rect">
             <a:avLst/>
@@ -9233,9 +9183,7 @@
             <a:ext cx="1874520" cy="877824"/>
           </a:xfrm>
           <a:prstGeom prst="rect">
-            <a:avLst>
-              <a:gd name="adj" fmla="val 5208"/>
-            </a:avLst>
+            <a:avLst/>
           </a:prstGeom>
           <a:solidFill>
             <a:srgbClr val="10281E"/>
@@ -9295,7 +9243,7 @@
         <p:spPr>
           <a:xfrm>
             <a:off x="3044952" y="3218688"/>
-            <a:ext cx="1545336" cy="91440"/>
+            <a:ext cx="1545336" cy="201168"/>
           </a:xfrm>
           <a:prstGeom prst="rect">
             <a:avLst/>
@@ -9336,9 +9284,7 @@
             <a:ext cx="1874520" cy="877824"/>
           </a:xfrm>
           <a:prstGeom prst="rect">
-            <a:avLst>
-              <a:gd name="adj" fmla="val 5208"/>
-            </a:avLst>
+            <a:avLst/>
           </a:prstGeom>
           <a:solidFill>
             <a:srgbClr val="10281E"/>
@@ -9398,7 +9344,7 @@
         <p:spPr>
           <a:xfrm>
             <a:off x="5193792" y="3218688"/>
-            <a:ext cx="1545336" cy="91440"/>
+            <a:ext cx="1545336" cy="201168"/>
           </a:xfrm>
           <a:prstGeom prst="rect">
             <a:avLst/>
@@ -9854,9 +9800,7 @@
             <a:ext cx="3063240" cy="2331720"/>
           </a:xfrm>
           <a:prstGeom prst="rect">
-            <a:avLst>
-              <a:gd name="adj" fmla="val 1961"/>
-            </a:avLst>
+            <a:avLst/>
           </a:prstGeom>
           <a:solidFill>
             <a:srgbClr val="1E3B2E"/>
@@ -9957,9 +9901,7 @@
             <a:ext cx="3063240" cy="2331720"/>
           </a:xfrm>
           <a:prstGeom prst="rect">
-            <a:avLst>
-              <a:gd name="adj" fmla="val 1961"/>
-            </a:avLst>
+            <a:avLst/>
           </a:prstGeom>
           <a:solidFill>
             <a:srgbClr val="FFFFFF"/>
@@ -10060,9 +10002,7 @@
             <a:ext cx="3063240" cy="2331720"/>
           </a:xfrm>
           <a:prstGeom prst="rect">
-            <a:avLst>
-              <a:gd name="adj" fmla="val 1961"/>
-            </a:avLst>
+            <a:avLst/>
           </a:prstGeom>
           <a:solidFill>
             <a:srgbClr val="FFFFFF"/>
@@ -10372,9 +10312,7 @@
             <a:ext cx="2468880" cy="1828800"/>
           </a:xfrm>
           <a:prstGeom prst="rect">
-            <a:avLst>
-              <a:gd name="adj" fmla="val 2500"/>
-            </a:avLst>
+            <a:avLst/>
           </a:prstGeom>
           <a:solidFill>
             <a:srgbClr val="FFFFFF"/>
@@ -10470,7 +10408,7 @@
         <p:spPr>
           <a:xfrm>
             <a:off x="804672" y="3392424"/>
-            <a:ext cx="2139696" cy="1042416"/>
+            <a:ext cx="2139696" cy="841248"/>
           </a:xfrm>
           <a:prstGeom prst="rect">
             <a:avLst/>
@@ -10681,9 +10619,7 @@
             <a:ext cx="2468880" cy="1828800"/>
           </a:xfrm>
           <a:prstGeom prst="rect">
-            <a:avLst>
-              <a:gd name="adj" fmla="val 2500"/>
-            </a:avLst>
+            <a:avLst/>
           </a:prstGeom>
           <a:solidFill>
             <a:srgbClr val="FFFFFF"/>
@@ -10779,7 +10715,7 @@
         <p:spPr>
           <a:xfrm>
             <a:off x="9217152" y="3392424"/>
-            <a:ext cx="2139696" cy="1042416"/>
+            <a:ext cx="2139696" cy="841248"/>
           </a:xfrm>
           <a:prstGeom prst="rect">
             <a:avLst/>
@@ -11844,9 +11780,7 @@
             <a:ext cx="3154680" cy="2286000"/>
           </a:xfrm>
           <a:prstGeom prst="rect">
-            <a:avLst>
-              <a:gd name="adj" fmla="val 2000"/>
-            </a:avLst>
+            <a:avLst/>
           </a:prstGeom>
           <a:solidFill>
             <a:srgbClr val="FFFFFF"/>
@@ -11947,9 +11881,7 @@
             <a:ext cx="3154680" cy="2286000"/>
           </a:xfrm>
           <a:prstGeom prst="rect">
-            <a:avLst>
-              <a:gd name="adj" fmla="val 2000"/>
-            </a:avLst>
+            <a:avLst/>
           </a:prstGeom>
           <a:solidFill>
             <a:srgbClr val="FFFFFF"/>
@@ -12050,9 +11982,7 @@
             <a:ext cx="3154680" cy="2286000"/>
           </a:xfrm>
           <a:prstGeom prst="rect">
-            <a:avLst>
-              <a:gd name="adj" fmla="val 2000"/>
-            </a:avLst>
+            <a:avLst/>
           </a:prstGeom>
           <a:solidFill>
             <a:srgbClr val="FFFFFF"/>
@@ -12377,9 +12307,7 @@
             <a:ext cx="1965960" cy="786384"/>
           </a:xfrm>
           <a:prstGeom prst="rect">
-            <a:avLst>
-              <a:gd name="adj" fmla="val 5814"/>
-            </a:avLst>
+            <a:avLst/>
           </a:prstGeom>
           <a:solidFill>
             <a:srgbClr val="1E3B2E"/>
@@ -12439,7 +12367,7 @@
         <p:spPr>
           <a:xfrm>
             <a:off x="4828032" y="2414016"/>
-            <a:ext cx="1636776" cy="0"/>
+            <a:ext cx="1636776" cy="201168"/>
           </a:xfrm>
           <a:prstGeom prst="rect">
             <a:avLst/>
@@ -12480,9 +12408,7 @@
             <a:ext cx="1965960" cy="786384"/>
           </a:xfrm>
           <a:prstGeom prst="rect">
-            <a:avLst>
-              <a:gd name="adj" fmla="val 5814"/>
-            </a:avLst>
+            <a:avLst/>
           </a:prstGeom>
           <a:solidFill>
             <a:srgbClr val="1E3B2E"/>
@@ -12542,7 +12468,7 @@
         <p:spPr>
           <a:xfrm>
             <a:off x="8165592" y="3630168"/>
-            <a:ext cx="1636776" cy="0"/>
+            <a:ext cx="1636776" cy="201168"/>
           </a:xfrm>
           <a:prstGeom prst="rect">
             <a:avLst/>
@@ -12583,9 +12509,7 @@
             <a:ext cx="1965960" cy="786384"/>
           </a:xfrm>
           <a:prstGeom prst="rect">
-            <a:avLst>
-              <a:gd name="adj" fmla="val 5814"/>
-            </a:avLst>
+            <a:avLst/>
           </a:prstGeom>
           <a:solidFill>
             <a:srgbClr val="1E3B2E"/>
@@ -12645,7 +12569,7 @@
         <p:spPr>
           <a:xfrm>
             <a:off x="6702552" y="5916168"/>
-            <a:ext cx="1636776" cy="0"/>
+            <a:ext cx="1636776" cy="201168"/>
           </a:xfrm>
           <a:prstGeom prst="rect">
             <a:avLst/>
@@ -12686,9 +12610,7 @@
             <a:ext cx="1965960" cy="786384"/>
           </a:xfrm>
           <a:prstGeom prst="rect">
-            <a:avLst>
-              <a:gd name="adj" fmla="val 5814"/>
-            </a:avLst>
+            <a:avLst/>
           </a:prstGeom>
           <a:solidFill>
             <a:srgbClr val="1E3B2E"/>
@@ -12748,7 +12670,7 @@
         <p:spPr>
           <a:xfrm>
             <a:off x="2587752" y="5916168"/>
-            <a:ext cx="1636776" cy="0"/>
+            <a:ext cx="1636776" cy="201168"/>
           </a:xfrm>
           <a:prstGeom prst="rect">
             <a:avLst/>
@@ -12789,9 +12711,7 @@
             <a:ext cx="1965960" cy="786384"/>
           </a:xfrm>
           <a:prstGeom prst="rect">
-            <a:avLst>
-              <a:gd name="adj" fmla="val 5814"/>
-            </a:avLst>
+            <a:avLst/>
           </a:prstGeom>
           <a:solidFill>
             <a:srgbClr val="1E3B2E"/>
@@ -12851,7 +12771,7 @@
         <p:spPr>
           <a:xfrm>
             <a:off x="1033272" y="3630168"/>
-            <a:ext cx="1636776" cy="0"/>
+            <a:ext cx="1636776" cy="201168"/>
           </a:xfrm>
           <a:prstGeom prst="rect">
             <a:avLst/>
@@ -13063,9 +12983,7 @@
             <a:ext cx="3886200" cy="868680"/>
           </a:xfrm>
           <a:prstGeom prst="rect">
-            <a:avLst>
-              <a:gd name="adj" fmla="val 5263"/>
-            </a:avLst>
+            <a:avLst/>
           </a:prstGeom>
           <a:solidFill>
             <a:srgbClr val="FFFFFF"/>
@@ -13125,7 +13043,7 @@
         <p:spPr>
           <a:xfrm>
             <a:off x="859536" y="2670048"/>
-            <a:ext cx="3557016" cy="82296"/>
+            <a:ext cx="3557016" cy="201168"/>
           </a:xfrm>
           <a:prstGeom prst="rect">
             <a:avLst/>
@@ -13166,9 +13084,7 @@
             <a:ext cx="3886200" cy="868680"/>
           </a:xfrm>
           <a:prstGeom prst="rect">
-            <a:avLst>
-              <a:gd name="adj" fmla="val 5263"/>
-            </a:avLst>
+            <a:avLst/>
           </a:prstGeom>
           <a:solidFill>
             <a:srgbClr val="FFFFFF"/>
@@ -13228,7 +13144,7 @@
         <p:spPr>
           <a:xfrm>
             <a:off x="859536" y="3813048"/>
-            <a:ext cx="3557016" cy="82296"/>
+            <a:ext cx="3557016" cy="201168"/>
           </a:xfrm>
           <a:prstGeom prst="rect">
             <a:avLst/>
@@ -13269,9 +13185,7 @@
             <a:ext cx="3886200" cy="868680"/>
           </a:xfrm>
           <a:prstGeom prst="rect">
-            <a:avLst>
-              <a:gd name="adj" fmla="val 5263"/>
-            </a:avLst>
+            <a:avLst/>
           </a:prstGeom>
           <a:solidFill>
             <a:srgbClr val="FFFFFF"/>
@@ -13331,7 +13245,7 @@
         <p:spPr>
           <a:xfrm>
             <a:off x="859536" y="4956048"/>
-            <a:ext cx="3557016" cy="82296"/>
+            <a:ext cx="3557016" cy="201168"/>
           </a:xfrm>
           <a:prstGeom prst="rect">
             <a:avLst/>

</xml_diff>